<commit_message>
updated powerpoint and added new test optimization
</commit_message>
<xml_diff>
--- a/Cuda Accelerated implementation of Traveling Salesman Problem using.pptx
+++ b/Cuda Accelerated implementation of Traveling Salesman Problem using.pptx
@@ -232,7 +232,7 @@
           <a:p>
             <a:fld id="{0DC994AA-C437-4EF4-8BEF-0B832D7FA420}" type="datetimeFigureOut">
               <a:rPr lang="en-US" smtClean="0"/>
-              <a:t>4/23/2026</a:t>
+              <a:t>4/27/2026</a:t>
             </a:fld>
             <a:endParaRPr lang="en-US"/>
           </a:p>
@@ -409,7 +409,7 @@
           <a:p>
             <a:fld id="{3B4FE048-FAD0-D943-9A17-3C4CB7633182}" type="datetimeFigureOut">
               <a:rPr lang="en-US" smtClean="0"/>
-              <a:t>4/23/2026</a:t>
+              <a:t>4/27/2026</a:t>
             </a:fld>
             <a:endParaRPr lang="en-US"/>
           </a:p>
@@ -676,6 +676,90 @@
 </p:notesMaster>
 </file>
 
+<file path=ppt/notesSlides/notesSlide1.xml><?xml version="1.0" encoding="utf-8"?>
+<p:notes xmlns:a="http://schemas.openxmlformats.org/drawingml/2006/main" xmlns:r="http://schemas.openxmlformats.org/officeDocument/2006/relationships" xmlns:p="http://schemas.openxmlformats.org/presentationml/2006/main">
+  <p:cSld>
+    <p:spTree>
+      <p:nvGrpSpPr>
+        <p:cNvPr id="1" name=""/>
+        <p:cNvGrpSpPr/>
+        <p:nvPr/>
+      </p:nvGrpSpPr>
+      <p:grpSpPr>
+        <a:xfrm>
+          <a:off x="0" y="0"/>
+          <a:ext cx="0" cy="0"/>
+          <a:chOff x="0" y="0"/>
+          <a:chExt cx="0" cy="0"/>
+        </a:xfrm>
+      </p:grpSpPr>
+      <p:sp>
+        <p:nvSpPr>
+          <p:cNvPr id="2" name="Slide Image Placeholder 1"/>
+          <p:cNvSpPr>
+            <a:spLocks noGrp="1" noRot="1" noChangeAspect="1"/>
+          </p:cNvSpPr>
+          <p:nvPr>
+            <p:ph type="sldImg"/>
+          </p:nvPr>
+        </p:nvSpPr>
+        <p:spPr/>
+      </p:sp>
+      <p:sp>
+        <p:nvSpPr>
+          <p:cNvPr id="3" name="Notes Placeholder 2"/>
+          <p:cNvSpPr>
+            <a:spLocks noGrp="1"/>
+          </p:cNvSpPr>
+          <p:nvPr>
+            <p:ph type="body" idx="1"/>
+          </p:nvPr>
+        </p:nvSpPr>
+        <p:spPr/>
+        <p:txBody>
+          <a:bodyPr/>
+          <a:lstStyle/>
+          <a:p>
+            <a:endParaRPr lang="en-US" dirty="0"/>
+          </a:p>
+        </p:txBody>
+      </p:sp>
+      <p:sp>
+        <p:nvSpPr>
+          <p:cNvPr id="4" name="Slide Number Placeholder 3"/>
+          <p:cNvSpPr>
+            <a:spLocks noGrp="1"/>
+          </p:cNvSpPr>
+          <p:nvPr>
+            <p:ph type="sldNum" sz="quarter" idx="5"/>
+          </p:nvPr>
+        </p:nvSpPr>
+        <p:spPr/>
+        <p:txBody>
+          <a:bodyPr/>
+          <a:lstStyle/>
+          <a:p>
+            <a:fld id="{55247812-3409-784D-BAE7-ABE53735D59F}" type="slidenum">
+              <a:rPr lang="en-US" smtClean="0"/>
+              <a:t>2</a:t>
+            </a:fld>
+            <a:endParaRPr lang="en-US"/>
+          </a:p>
+        </p:txBody>
+      </p:sp>
+    </p:spTree>
+    <p:extLst>
+      <p:ext uri="{BB962C8B-B14F-4D97-AF65-F5344CB8AC3E}">
+        <p14:creationId xmlns:p14="http://schemas.microsoft.com/office/powerpoint/2010/main" val="588718180"/>
+      </p:ext>
+    </p:extLst>
+  </p:cSld>
+  <p:clrMapOvr>
+    <a:masterClrMapping/>
+  </p:clrMapOvr>
+</p:notes>
+</file>
+
 <file path=ppt/slideLayouts/slideLayout1.xml><?xml version="1.0" encoding="utf-8"?>
 <p:sldLayout xmlns:a="http://schemas.openxmlformats.org/drawingml/2006/main" xmlns:r="http://schemas.openxmlformats.org/officeDocument/2006/relationships" xmlns:p="http://schemas.openxmlformats.org/presentationml/2006/main" preserve="1" userDrawn="1">
   <p:cSld name="Title Only">
@@ -1241,7 +1325,7 @@
           <a:p>
             <a:fld id="{D6D8061D-18C3-4F4F-85EF-561633F58754}" type="datetimeFigureOut">
               <a:rPr lang="en-US" smtClean="0"/>
-              <a:t>4/23/2026</a:t>
+              <a:t>4/27/2026</a:t>
             </a:fld>
             <a:endParaRPr lang="en-US"/>
           </a:p>
@@ -1426,7 +1510,7 @@
           <a:p>
             <a:fld id="{D6D8061D-18C3-4F4F-85EF-561633F58754}" type="datetimeFigureOut">
               <a:rPr lang="en-US" smtClean="0"/>
-              <a:t>4/23/2026</a:t>
+              <a:t>4/27/2026</a:t>
             </a:fld>
             <a:endParaRPr lang="en-US"/>
           </a:p>
@@ -3169,7 +3253,7 @@
           <a:p>
             <a:fld id="{D6D8061D-18C3-4F4F-85EF-561633F58754}" type="datetimeFigureOut">
               <a:rPr lang="en-US" smtClean="0"/>
-              <a:t>4/23/2026</a:t>
+              <a:t>4/27/2026</a:t>
             </a:fld>
             <a:endParaRPr lang="en-US"/>
           </a:p>
@@ -3604,7 +3688,7 @@
           <a:p>
             <a:fld id="{D6D8061D-18C3-4F4F-85EF-561633F58754}" type="datetimeFigureOut">
               <a:rPr lang="en-US" smtClean="0"/>
-              <a:t>4/23/2026</a:t>
+              <a:t>4/27/2026</a:t>
             </a:fld>
             <a:endParaRPr lang="en-US"/>
           </a:p>
@@ -4263,7 +4347,7 @@
           <a:p>
             <a:fld id="{D6D8061D-18C3-4F4F-85EF-561633F58754}" type="datetimeFigureOut">
               <a:rPr lang="en-US" smtClean="0"/>
-              <a:t>4/23/2026</a:t>
+              <a:t>4/27/2026</a:t>
             </a:fld>
             <a:endParaRPr lang="en-US"/>
           </a:p>
@@ -4530,7 +4614,7 @@
           <a:p>
             <a:fld id="{D6D8061D-18C3-4F4F-85EF-561633F58754}" type="datetimeFigureOut">
               <a:rPr lang="en-US" smtClean="0"/>
-              <a:t>4/23/2026</a:t>
+              <a:t>4/27/2026</a:t>
             </a:fld>
             <a:endParaRPr lang="en-US"/>
           </a:p>
@@ -5409,7 +5493,7 @@
         <p:spPr>
           <a:xfrm>
             <a:off x="417443" y="1855304"/>
-            <a:ext cx="11178209" cy="1477328"/>
+            <a:ext cx="11178209" cy="4801314"/>
           </a:xfrm>
           <a:prstGeom prst="rect">
             <a:avLst/>
@@ -5421,6 +5505,57 @@
             <a:spAutoFit/>
           </a:bodyPr>
           <a:lstStyle/>
+          <a:p>
+            <a:r>
+              <a:rPr lang="en-US" dirty="0">
+                <a:solidFill>
+                  <a:schemeClr val="bg1"/>
+                </a:solidFill>
+              </a:rPr>
+              <a:t>Placeholder Results and Conclusions</a:t>
+            </a:r>
+          </a:p>
+          <a:p>
+            <a:endParaRPr lang="en-US" dirty="0">
+              <a:solidFill>
+                <a:schemeClr val="bg1"/>
+              </a:solidFill>
+            </a:endParaRPr>
+          </a:p>
+          <a:p>
+            <a:r>
+              <a:rPr lang="en-US" dirty="0">
+                <a:solidFill>
+                  <a:schemeClr val="bg1"/>
+                </a:solidFill>
+              </a:rPr>
+              <a:t>At this stage, the reported results are preliminary and should be treated as placeholders. The project has established the baseline implementations and identified several promising CUDA optimization techniques, including improved memory coalescing, GPU-resident population evolution, and possible 2-opt local search improvements. However, these optimizations have not yet been fully implemented, benchmarked, or validated.</a:t>
+            </a:r>
+          </a:p>
+          <a:p>
+            <a:endParaRPr lang="en-US" dirty="0">
+              <a:solidFill>
+                <a:schemeClr val="bg1"/>
+              </a:solidFill>
+            </a:endParaRPr>
+          </a:p>
+          <a:p>
+            <a:r>
+              <a:rPr lang="en-US" dirty="0">
+                <a:solidFill>
+                  <a:schemeClr val="bg1"/>
+                </a:solidFill>
+              </a:rPr>
+              <a:t>The current conclusion is that CUDA offers strong potential for accelerating the Traveling Salesman genetic algorithm, especially in the fitness-evaluation stage where many tours can be processed in parallel. Future work will focus on implementing the proposed optimizations, measuring their effect on runtime and solution quality, and comparing the optimized GPU versions against the sequential and naive CUDA baselines.</a:t>
+            </a:r>
+          </a:p>
+          <a:p>
+            <a:endParaRPr lang="en-US" dirty="0">
+              <a:solidFill>
+                <a:schemeClr val="bg1"/>
+              </a:solidFill>
+            </a:endParaRPr>
+          </a:p>
           <a:p>
             <a:r>
               <a:rPr lang="en-US" dirty="0">
@@ -5594,7 +5729,7 @@
           <a:p>
             <a:r>
               <a:rPr lang="en-US" dirty="0"/>
-              <a:t>Introduction</a:t>
+              <a:t>ABSTRACT</a:t>
             </a:r>
           </a:p>
         </p:txBody>
@@ -5614,7 +5749,7 @@
         <p:spPr>
           <a:xfrm>
             <a:off x="417443" y="1855304"/>
-            <a:ext cx="11178209" cy="4524315"/>
+            <a:ext cx="11178209" cy="3046988"/>
           </a:xfrm>
           <a:prstGeom prst="rect">
             <a:avLst/>
@@ -5628,220 +5763,29 @@
           <a:lstStyle/>
           <a:p>
             <a:r>
-              <a:rPr lang="en-US" dirty="0">
+              <a:rPr lang="en-US" sz="2400" dirty="0">
                 <a:solidFill>
                   <a:schemeClr val="bg1"/>
                 </a:solidFill>
               </a:rPr>
-              <a:t>Four score and seven years ago,</a:t>
-            </a:r>
-          </a:p>
-          <a:p>
-            <a:r>
-              <a:rPr lang="en-US" dirty="0">
+              <a:t>This project explores GPU-accelerated approaches to solving the Traveling Salesman Problem, a classic optimization challenge where the goal is to find the shortest possible route through a set of cities. Starting from a Python baseline, the project builds and compares a sequential C genetic algorithm, a naive CUDA implementation, and more advanced CUDA genetic algorithm variants.  Numerous approaches to </a:t>
+            </a:r>
+            <a:r>
+              <a:rPr lang="en-US" sz="2400" dirty="0" err="1">
                 <a:solidFill>
                   <a:schemeClr val="bg1"/>
                 </a:solidFill>
               </a:rPr>
-              <a:t>Blay </a:t>
-            </a:r>
-            <a:r>
-              <a:rPr lang="en-US" dirty="0" err="1">
+              <a:t>optimizint</a:t>
+            </a:r>
+            <a:r>
+              <a:rPr lang="en-US" sz="2400" dirty="0">
                 <a:solidFill>
                   <a:schemeClr val="bg1"/>
                 </a:solidFill>
               </a:rPr>
-              <a:t>blahasdf</a:t>
-            </a:r>
-            <a:endParaRPr lang="en-US" dirty="0">
-              <a:solidFill>
-                <a:schemeClr val="bg1"/>
-              </a:solidFill>
-            </a:endParaRPr>
-          </a:p>
-          <a:p>
-            <a:r>
-              <a:rPr lang="en-US" dirty="0" err="1">
-                <a:solidFill>
-                  <a:schemeClr val="bg1"/>
-                </a:solidFill>
-              </a:rPr>
-              <a:t>Asdf</a:t>
-            </a:r>
-            <a:endParaRPr lang="en-US" dirty="0">
-              <a:solidFill>
-                <a:schemeClr val="bg1"/>
-              </a:solidFill>
-            </a:endParaRPr>
-          </a:p>
-          <a:p>
-            <a:r>
-              <a:rPr lang="en-US" dirty="0" err="1">
-                <a:solidFill>
-                  <a:schemeClr val="bg1"/>
-                </a:solidFill>
-              </a:rPr>
-              <a:t>Asdf</a:t>
-            </a:r>
-            <a:endParaRPr lang="en-US" dirty="0">
-              <a:solidFill>
-                <a:schemeClr val="bg1"/>
-              </a:solidFill>
-            </a:endParaRPr>
-          </a:p>
-          <a:p>
-            <a:r>
-              <a:rPr lang="en-US" dirty="0">
-                <a:solidFill>
-                  <a:schemeClr val="bg1"/>
-                </a:solidFill>
-              </a:rPr>
-              <a:t>As</a:t>
-            </a:r>
-          </a:p>
-          <a:p>
-            <a:r>
-              <a:rPr lang="en-US" dirty="0" err="1">
-                <a:solidFill>
-                  <a:schemeClr val="bg1"/>
-                </a:solidFill>
-              </a:rPr>
-              <a:t>Fd</a:t>
-            </a:r>
-            <a:endParaRPr lang="en-US" dirty="0">
-              <a:solidFill>
-                <a:schemeClr val="bg1"/>
-              </a:solidFill>
-            </a:endParaRPr>
-          </a:p>
-          <a:p>
-            <a:r>
-              <a:rPr lang="en-US" dirty="0" err="1">
-                <a:solidFill>
-                  <a:schemeClr val="bg1"/>
-                </a:solidFill>
-              </a:rPr>
-              <a:t>Asdfas</a:t>
-            </a:r>
-            <a:endParaRPr lang="en-US" dirty="0">
-              <a:solidFill>
-                <a:schemeClr val="bg1"/>
-              </a:solidFill>
-            </a:endParaRPr>
-          </a:p>
-          <a:p>
-            <a:r>
-              <a:rPr lang="en-US" dirty="0" err="1">
-                <a:solidFill>
-                  <a:schemeClr val="bg1"/>
-                </a:solidFill>
-              </a:rPr>
-              <a:t>Df</a:t>
-            </a:r>
-            <a:endParaRPr lang="en-US" dirty="0">
-              <a:solidFill>
-                <a:schemeClr val="bg1"/>
-              </a:solidFill>
-            </a:endParaRPr>
-          </a:p>
-          <a:p>
-            <a:endParaRPr lang="en-US" dirty="0">
-              <a:solidFill>
-                <a:schemeClr val="bg1"/>
-              </a:solidFill>
-            </a:endParaRPr>
-          </a:p>
-          <a:p>
-            <a:r>
-              <a:rPr lang="en-US" dirty="0" err="1">
-                <a:solidFill>
-                  <a:schemeClr val="bg1"/>
-                </a:solidFill>
-              </a:rPr>
-              <a:t>Dsf</a:t>
-            </a:r>
-            <a:endParaRPr lang="en-US" dirty="0">
-              <a:solidFill>
-                <a:schemeClr val="bg1"/>
-              </a:solidFill>
-            </a:endParaRPr>
-          </a:p>
-          <a:p>
-            <a:r>
-              <a:rPr lang="en-US" dirty="0" err="1">
-                <a:solidFill>
-                  <a:schemeClr val="bg1"/>
-                </a:solidFill>
-              </a:rPr>
-              <a:t>Asd</a:t>
-            </a:r>
-            <a:endParaRPr lang="en-US" dirty="0">
-              <a:solidFill>
-                <a:schemeClr val="bg1"/>
-              </a:solidFill>
-            </a:endParaRPr>
-          </a:p>
-          <a:p>
-            <a:r>
-              <a:rPr lang="en-US" dirty="0">
-                <a:solidFill>
-                  <a:schemeClr val="bg1"/>
-                </a:solidFill>
-              </a:rPr>
-              <a:t>F</a:t>
-            </a:r>
-          </a:p>
-          <a:p>
-            <a:r>
-              <a:rPr lang="en-US" dirty="0" err="1">
-                <a:solidFill>
-                  <a:schemeClr val="bg1"/>
-                </a:solidFill>
-              </a:rPr>
-              <a:t>Asdf</a:t>
-            </a:r>
-            <a:endParaRPr lang="en-US" dirty="0">
-              <a:solidFill>
-                <a:schemeClr val="bg1"/>
-              </a:solidFill>
-            </a:endParaRPr>
-          </a:p>
-          <a:p>
-            <a:r>
-              <a:rPr lang="en-US" dirty="0" err="1">
-                <a:solidFill>
-                  <a:schemeClr val="bg1"/>
-                </a:solidFill>
-              </a:rPr>
-              <a:t>Asdf</a:t>
-            </a:r>
-            <a:endParaRPr lang="en-US" dirty="0">
-              <a:solidFill>
-                <a:schemeClr val="bg1"/>
-              </a:solidFill>
-            </a:endParaRPr>
-          </a:p>
-          <a:p>
-            <a:endParaRPr lang="en-US" dirty="0">
-              <a:solidFill>
-                <a:schemeClr val="bg1"/>
-              </a:solidFill>
-            </a:endParaRPr>
-          </a:p>
-          <a:p>
-            <a:r>
-              <a:rPr lang="en-US" dirty="0" err="1">
-                <a:solidFill>
-                  <a:schemeClr val="bg1"/>
-                </a:solidFill>
-              </a:rPr>
-              <a:t>asdf</a:t>
-            </a:r>
-            <a:endParaRPr lang="en-US" dirty="0">
-              <a:solidFill>
-                <a:schemeClr val="bg1"/>
-              </a:solidFill>
-            </a:endParaRPr>
+              <a:t> the CUDA implementation, with specific focus on the tour length calculation were explored.  The main focus is understanding how GPU parallelism, memory layout, and reduced CPU-GPU communication can improve performance while preserving solution quality.</a:t>
+            </a:r>
           </a:p>
         </p:txBody>
       </p:sp>
@@ -5929,7 +5873,7 @@
         <p:spPr>
           <a:xfrm>
             <a:off x="417443" y="1855304"/>
-            <a:ext cx="11178209" cy="4524315"/>
+            <a:ext cx="11178209" cy="3693319"/>
           </a:xfrm>
           <a:prstGeom prst="rect">
             <a:avLst/>
@@ -5948,25 +5892,138 @@
                   <a:schemeClr val="bg1"/>
                 </a:solidFill>
               </a:rPr>
-              <a:t>Four score and seven years ago,</a:t>
-            </a:r>
-          </a:p>
-          <a:p>
+              <a:t>Traveling salesman is a canonical NP hard problem in computer science, attempting to find a </a:t>
+            </a:r>
+            <a:r>
+              <a:rPr lang="en-US" dirty="0" err="1">
+                <a:solidFill>
+                  <a:schemeClr val="bg1"/>
+                </a:solidFill>
+              </a:rPr>
+              <a:t>Hamilitonian</a:t>
+            </a:r>
             <a:r>
               <a:rPr lang="en-US" dirty="0">
                 <a:solidFill>
                   <a:schemeClr val="bg1"/>
                 </a:solidFill>
               </a:rPr>
-              <a:t>Blay </a:t>
-            </a:r>
+              <a:t> circuit in an undirected digraph.  This is to say find a tour which visits each node exactly once, while minimizing the distance traveled.</a:t>
+            </a:r>
+          </a:p>
+          <a:p>
+            <a:endParaRPr lang="en-US" dirty="0">
+              <a:solidFill>
+                <a:schemeClr val="bg1"/>
+              </a:solidFill>
+            </a:endParaRPr>
+          </a:p>
+          <a:p>
+            <a:r>
+              <a:rPr lang="en-US" dirty="0">
+                <a:solidFill>
+                  <a:schemeClr val="bg1"/>
+                </a:solidFill>
+              </a:rPr>
+              <a:t>While humans are intrinsically good at finding</a:t>
+            </a:r>
+          </a:p>
+          <a:p>
+            <a:r>
+              <a:rPr lang="en-US" dirty="0">
+                <a:solidFill>
+                  <a:schemeClr val="bg1"/>
+                </a:solidFill>
+              </a:rPr>
+              <a:t>solutions to this problem, the combinatorial</a:t>
+            </a:r>
+          </a:p>
+          <a:p>
+            <a:r>
+              <a:rPr lang="en-US" dirty="0">
+                <a:solidFill>
+                  <a:schemeClr val="bg1"/>
+                </a:solidFill>
+              </a:rPr>
+              <a:t>explosion of city combinations means that a</a:t>
+            </a:r>
+          </a:p>
+          <a:p>
+            <a:r>
+              <a:rPr lang="en-US" dirty="0">
+                <a:solidFill>
+                  <a:schemeClr val="bg1"/>
+                </a:solidFill>
+              </a:rPr>
+              <a:t>computer algorithm will struggle find good results.</a:t>
+            </a:r>
+          </a:p>
+          <a:p>
+            <a:endParaRPr lang="en-US" dirty="0">
+              <a:solidFill>
+                <a:schemeClr val="bg1"/>
+              </a:solidFill>
+            </a:endParaRPr>
+          </a:p>
+          <a:p>
+            <a:r>
+              <a:rPr lang="en-US" dirty="0">
+                <a:solidFill>
+                  <a:schemeClr val="bg1"/>
+                </a:solidFill>
+              </a:rPr>
+              <a:t>However, applicable to CUDA, the problem is </a:t>
+            </a:r>
+          </a:p>
+          <a:p>
             <a:r>
               <a:rPr lang="en-US" dirty="0" err="1">
                 <a:solidFill>
                   <a:schemeClr val="bg1"/>
                 </a:solidFill>
               </a:rPr>
-              <a:t>blahasdf</a:t>
+              <a:t>Embarassingly</a:t>
+            </a:r>
+            <a:r>
+              <a:rPr lang="en-US" dirty="0">
+                <a:solidFill>
+                  <a:schemeClr val="bg1"/>
+                </a:solidFill>
+              </a:rPr>
+              <a:t> Parallelizable.  Even with this trait</a:t>
+            </a:r>
+            <a:br>
+              <a:rPr lang="en-US" dirty="0">
+                <a:solidFill>
+                  <a:schemeClr val="bg1"/>
+                </a:solidFill>
+              </a:rPr>
+            </a:br>
+            <a:r>
+              <a:rPr lang="en-US" dirty="0">
+                <a:solidFill>
+                  <a:schemeClr val="bg1"/>
+                </a:solidFill>
+              </a:rPr>
+              <a:t>the sheet magnitude of the issue means that </a:t>
+            </a:r>
+          </a:p>
+          <a:p>
+            <a:r>
+              <a:rPr lang="en-US" dirty="0">
+                <a:solidFill>
+                  <a:schemeClr val="bg1"/>
+                </a:solidFill>
+              </a:rPr>
+              <a:t>some more </a:t>
+            </a:r>
+            <a:r>
+              <a:rPr lang="en-US">
+                <a:solidFill>
+                  <a:schemeClr val="bg1"/>
+                </a:solidFill>
+              </a:rPr>
+              <a:t>advanced technique is needed.</a:t>
             </a:r>
             <a:endParaRPr lang="en-US" dirty="0">
               <a:solidFill>
@@ -5974,192 +6031,55 @@
               </a:solidFill>
             </a:endParaRPr>
           </a:p>
-          <a:p>
-            <a:r>
-              <a:rPr lang="en-US" dirty="0" err="1">
+        </p:txBody>
+      </p:sp>
+      <p:pic>
+        <p:nvPicPr>
+          <p:cNvPr id="1028" name="Picture 4">
+            <a:extLst>
+              <a:ext uri="{FF2B5EF4-FFF2-40B4-BE49-F238E27FC236}">
+                <a16:creationId xmlns:a16="http://schemas.microsoft.com/office/drawing/2014/main" id="{AF4DA40A-5135-90BA-4CBB-34ACB9258E77}"/>
+              </a:ext>
+            </a:extLst>
+          </p:cNvPr>
+          <p:cNvPicPr>
+            <a:picLocks noChangeAspect="1" noChangeArrowheads="1"/>
+          </p:cNvPicPr>
+          <p:nvPr/>
+        </p:nvPicPr>
+        <p:blipFill>
+          <a:blip r:embed="rId2">
+            <a:extLst>
+              <a:ext uri="{28A0092B-C50C-407E-A947-70E740481C1C}">
+                <a14:useLocalDpi xmlns:a14="http://schemas.microsoft.com/office/drawing/2010/main" val="0"/>
+              </a:ext>
+            </a:extLst>
+          </a:blip>
+          <a:srcRect/>
+          <a:stretch>
+            <a:fillRect/>
+          </a:stretch>
+        </p:blipFill>
+        <p:spPr bwMode="auto">
+          <a:xfrm>
+            <a:off x="5194735" y="3012737"/>
+            <a:ext cx="6400917" cy="3366882"/>
+          </a:xfrm>
+          <a:prstGeom prst="rect">
+            <a:avLst/>
+          </a:prstGeom>
+          <a:noFill/>
+          <a:extLst>
+            <a:ext uri="{909E8E84-426E-40DD-AFC4-6F175D3DCCD1}">
+              <a14:hiddenFill xmlns:a14="http://schemas.microsoft.com/office/drawing/2010/main">
                 <a:solidFill>
-                  <a:schemeClr val="bg1"/>
+                  <a:srgbClr val="FFFFFF"/>
                 </a:solidFill>
-              </a:rPr>
-              <a:t>Asdf</a:t>
-            </a:r>
-            <a:endParaRPr lang="en-US" dirty="0">
-              <a:solidFill>
-                <a:schemeClr val="bg1"/>
-              </a:solidFill>
-            </a:endParaRPr>
-          </a:p>
-          <a:p>
-            <a:r>
-              <a:rPr lang="en-US" dirty="0" err="1">
-                <a:solidFill>
-                  <a:schemeClr val="bg1"/>
-                </a:solidFill>
-              </a:rPr>
-              <a:t>Asdf</a:t>
-            </a:r>
-            <a:endParaRPr lang="en-US" dirty="0">
-              <a:solidFill>
-                <a:schemeClr val="bg1"/>
-              </a:solidFill>
-            </a:endParaRPr>
-          </a:p>
-          <a:p>
-            <a:r>
-              <a:rPr lang="en-US" dirty="0">
-                <a:solidFill>
-                  <a:schemeClr val="bg1"/>
-                </a:solidFill>
-              </a:rPr>
-              <a:t>As</a:t>
-            </a:r>
-          </a:p>
-          <a:p>
-            <a:r>
-              <a:rPr lang="en-US" dirty="0" err="1">
-                <a:solidFill>
-                  <a:schemeClr val="bg1"/>
-                </a:solidFill>
-              </a:rPr>
-              <a:t>Fd</a:t>
-            </a:r>
-            <a:endParaRPr lang="en-US" dirty="0">
-              <a:solidFill>
-                <a:schemeClr val="bg1"/>
-              </a:solidFill>
-            </a:endParaRPr>
-          </a:p>
-          <a:p>
-            <a:r>
-              <a:rPr lang="en-US" dirty="0" err="1">
-                <a:solidFill>
-                  <a:schemeClr val="bg1"/>
-                </a:solidFill>
-              </a:rPr>
-              <a:t>Asdfas</a:t>
-            </a:r>
-            <a:endParaRPr lang="en-US" dirty="0">
-              <a:solidFill>
-                <a:schemeClr val="bg1"/>
-              </a:solidFill>
-            </a:endParaRPr>
-          </a:p>
-          <a:p>
-            <a:r>
-              <a:rPr lang="en-US" dirty="0" err="1">
-                <a:solidFill>
-                  <a:schemeClr val="bg1"/>
-                </a:solidFill>
-              </a:rPr>
-              <a:t>Df</a:t>
-            </a:r>
-            <a:endParaRPr lang="en-US" dirty="0">
-              <a:solidFill>
-                <a:schemeClr val="bg1"/>
-              </a:solidFill>
-            </a:endParaRPr>
-          </a:p>
-          <a:p>
-            <a:endParaRPr lang="en-US" dirty="0">
-              <a:solidFill>
-                <a:schemeClr val="bg1"/>
-              </a:solidFill>
-            </a:endParaRPr>
-          </a:p>
-          <a:p>
-            <a:r>
-              <a:rPr lang="en-US" dirty="0" err="1">
-                <a:solidFill>
-                  <a:schemeClr val="bg1"/>
-                </a:solidFill>
-              </a:rPr>
-              <a:t>Dsf</a:t>
-            </a:r>
-            <a:endParaRPr lang="en-US" dirty="0">
-              <a:solidFill>
-                <a:schemeClr val="bg1"/>
-              </a:solidFill>
-            </a:endParaRPr>
-          </a:p>
-          <a:p>
-            <a:r>
-              <a:rPr lang="en-US" dirty="0" err="1">
-                <a:solidFill>
-                  <a:schemeClr val="bg1"/>
-                </a:solidFill>
-              </a:rPr>
-              <a:t>Asd</a:t>
-            </a:r>
-            <a:endParaRPr lang="en-US" dirty="0">
-              <a:solidFill>
-                <a:schemeClr val="bg1"/>
-              </a:solidFill>
-            </a:endParaRPr>
-          </a:p>
-          <a:p>
-            <a:r>
-              <a:rPr lang="en-US" dirty="0">
-                <a:solidFill>
-                  <a:schemeClr val="bg1"/>
-                </a:solidFill>
-              </a:rPr>
-              <a:t>F</a:t>
-            </a:r>
-          </a:p>
-          <a:p>
-            <a:r>
-              <a:rPr lang="en-US" dirty="0" err="1">
-                <a:solidFill>
-                  <a:schemeClr val="bg1"/>
-                </a:solidFill>
-              </a:rPr>
-              <a:t>Asdf</a:t>
-            </a:r>
-            <a:endParaRPr lang="en-US" dirty="0">
-              <a:solidFill>
-                <a:schemeClr val="bg1"/>
-              </a:solidFill>
-            </a:endParaRPr>
-          </a:p>
-          <a:p>
-            <a:r>
-              <a:rPr lang="en-US" dirty="0" err="1">
-                <a:solidFill>
-                  <a:schemeClr val="bg1"/>
-                </a:solidFill>
-              </a:rPr>
-              <a:t>Asdf</a:t>
-            </a:r>
-            <a:endParaRPr lang="en-US" dirty="0">
-              <a:solidFill>
-                <a:schemeClr val="bg1"/>
-              </a:solidFill>
-            </a:endParaRPr>
-          </a:p>
-          <a:p>
-            <a:endParaRPr lang="en-US" dirty="0">
-              <a:solidFill>
-                <a:schemeClr val="bg1"/>
-              </a:solidFill>
-            </a:endParaRPr>
-          </a:p>
-          <a:p>
-            <a:r>
-              <a:rPr lang="en-US" dirty="0" err="1">
-                <a:solidFill>
-                  <a:schemeClr val="bg1"/>
-                </a:solidFill>
-              </a:rPr>
-              <a:t>asdf</a:t>
-            </a:r>
-            <a:endParaRPr lang="en-US" dirty="0">
-              <a:solidFill>
-                <a:schemeClr val="bg1"/>
-              </a:solidFill>
-            </a:endParaRPr>
-          </a:p>
-        </p:txBody>
-      </p:sp>
+              </a14:hiddenFill>
+            </a:ext>
+          </a:extLst>
+        </p:spPr>
+      </p:pic>
     </p:spTree>
     <p:extLst>
       <p:ext uri="{BB962C8B-B14F-4D97-AF65-F5344CB8AC3E}">
@@ -6244,7 +6164,7 @@
         <p:spPr>
           <a:xfrm>
             <a:off x="417443" y="1855304"/>
-            <a:ext cx="11178209" cy="4524315"/>
+            <a:ext cx="11178209" cy="646331"/>
           </a:xfrm>
           <a:prstGeom prst="rect">
             <a:avLst/>
@@ -6258,220 +6178,21 @@
           <a:lstStyle/>
           <a:p>
             <a:r>
+              <a:rPr lang="en-US" dirty="0" err="1">
+                <a:solidFill>
+                  <a:schemeClr val="bg1"/>
+                </a:solidFill>
+              </a:rPr>
+              <a:t>Genentic</a:t>
+            </a:r>
+            <a:r>
               <a:rPr lang="en-US" dirty="0">
                 <a:solidFill>
                   <a:schemeClr val="bg1"/>
                 </a:solidFill>
               </a:rPr>
-              <a:t>Four score and seven years ago,</a:t>
-            </a:r>
-          </a:p>
-          <a:p>
-            <a:r>
-              <a:rPr lang="en-US" dirty="0">
-                <a:solidFill>
-                  <a:schemeClr val="bg1"/>
-                </a:solidFill>
-              </a:rPr>
-              <a:t>Blay </a:t>
-            </a:r>
-            <a:r>
-              <a:rPr lang="en-US" dirty="0" err="1">
-                <a:solidFill>
-                  <a:schemeClr val="bg1"/>
-                </a:solidFill>
-              </a:rPr>
-              <a:t>blahasdf</a:t>
-            </a:r>
-            <a:endParaRPr lang="en-US" dirty="0">
-              <a:solidFill>
-                <a:schemeClr val="bg1"/>
-              </a:solidFill>
-            </a:endParaRPr>
-          </a:p>
-          <a:p>
-            <a:r>
-              <a:rPr lang="en-US" dirty="0" err="1">
-                <a:solidFill>
-                  <a:schemeClr val="bg1"/>
-                </a:solidFill>
-              </a:rPr>
-              <a:t>Asdf</a:t>
-            </a:r>
-            <a:endParaRPr lang="en-US" dirty="0">
-              <a:solidFill>
-                <a:schemeClr val="bg1"/>
-              </a:solidFill>
-            </a:endParaRPr>
-          </a:p>
-          <a:p>
-            <a:r>
-              <a:rPr lang="en-US" dirty="0" err="1">
-                <a:solidFill>
-                  <a:schemeClr val="bg1"/>
-                </a:solidFill>
-              </a:rPr>
-              <a:t>Asdf</a:t>
-            </a:r>
-            <a:endParaRPr lang="en-US" dirty="0">
-              <a:solidFill>
-                <a:schemeClr val="bg1"/>
-              </a:solidFill>
-            </a:endParaRPr>
-          </a:p>
-          <a:p>
-            <a:r>
-              <a:rPr lang="en-US" dirty="0">
-                <a:solidFill>
-                  <a:schemeClr val="bg1"/>
-                </a:solidFill>
-              </a:rPr>
-              <a:t>As</a:t>
-            </a:r>
-          </a:p>
-          <a:p>
-            <a:r>
-              <a:rPr lang="en-US" dirty="0" err="1">
-                <a:solidFill>
-                  <a:schemeClr val="bg1"/>
-                </a:solidFill>
-              </a:rPr>
-              <a:t>Fd</a:t>
-            </a:r>
-            <a:endParaRPr lang="en-US" dirty="0">
-              <a:solidFill>
-                <a:schemeClr val="bg1"/>
-              </a:solidFill>
-            </a:endParaRPr>
-          </a:p>
-          <a:p>
-            <a:r>
-              <a:rPr lang="en-US" dirty="0" err="1">
-                <a:solidFill>
-                  <a:schemeClr val="bg1"/>
-                </a:solidFill>
-              </a:rPr>
-              <a:t>Asdfas</a:t>
-            </a:r>
-            <a:endParaRPr lang="en-US" dirty="0">
-              <a:solidFill>
-                <a:schemeClr val="bg1"/>
-              </a:solidFill>
-            </a:endParaRPr>
-          </a:p>
-          <a:p>
-            <a:r>
-              <a:rPr lang="en-US" dirty="0" err="1">
-                <a:solidFill>
-                  <a:schemeClr val="bg1"/>
-                </a:solidFill>
-              </a:rPr>
-              <a:t>Df</a:t>
-            </a:r>
-            <a:endParaRPr lang="en-US" dirty="0">
-              <a:solidFill>
-                <a:schemeClr val="bg1"/>
-              </a:solidFill>
-            </a:endParaRPr>
-          </a:p>
-          <a:p>
-            <a:endParaRPr lang="en-US" dirty="0">
-              <a:solidFill>
-                <a:schemeClr val="bg1"/>
-              </a:solidFill>
-            </a:endParaRPr>
-          </a:p>
-          <a:p>
-            <a:r>
-              <a:rPr lang="en-US" dirty="0" err="1">
-                <a:solidFill>
-                  <a:schemeClr val="bg1"/>
-                </a:solidFill>
-              </a:rPr>
-              <a:t>Dsf</a:t>
-            </a:r>
-            <a:endParaRPr lang="en-US" dirty="0">
-              <a:solidFill>
-                <a:schemeClr val="bg1"/>
-              </a:solidFill>
-            </a:endParaRPr>
-          </a:p>
-          <a:p>
-            <a:r>
-              <a:rPr lang="en-US" dirty="0" err="1">
-                <a:solidFill>
-                  <a:schemeClr val="bg1"/>
-                </a:solidFill>
-              </a:rPr>
-              <a:t>Asd</a:t>
-            </a:r>
-            <a:endParaRPr lang="en-US" dirty="0">
-              <a:solidFill>
-                <a:schemeClr val="bg1"/>
-              </a:solidFill>
-            </a:endParaRPr>
-          </a:p>
-          <a:p>
-            <a:r>
-              <a:rPr lang="en-US" dirty="0">
-                <a:solidFill>
-                  <a:schemeClr val="bg1"/>
-                </a:solidFill>
-              </a:rPr>
-              <a:t>F</a:t>
-            </a:r>
-          </a:p>
-          <a:p>
-            <a:r>
-              <a:rPr lang="en-US" dirty="0" err="1">
-                <a:solidFill>
-                  <a:schemeClr val="bg1"/>
-                </a:solidFill>
-              </a:rPr>
-              <a:t>Asdf</a:t>
-            </a:r>
-            <a:endParaRPr lang="en-US" dirty="0">
-              <a:solidFill>
-                <a:schemeClr val="bg1"/>
-              </a:solidFill>
-            </a:endParaRPr>
-          </a:p>
-          <a:p>
-            <a:r>
-              <a:rPr lang="en-US" dirty="0" err="1">
-                <a:solidFill>
-                  <a:schemeClr val="bg1"/>
-                </a:solidFill>
-              </a:rPr>
-              <a:t>Asdf</a:t>
-            </a:r>
-            <a:endParaRPr lang="en-US" dirty="0">
-              <a:solidFill>
-                <a:schemeClr val="bg1"/>
-              </a:solidFill>
-            </a:endParaRPr>
-          </a:p>
-          <a:p>
-            <a:endParaRPr lang="en-US" dirty="0">
-              <a:solidFill>
-                <a:schemeClr val="bg1"/>
-              </a:solidFill>
-            </a:endParaRPr>
-          </a:p>
-          <a:p>
-            <a:r>
-              <a:rPr lang="en-US" dirty="0" err="1">
-                <a:solidFill>
-                  <a:schemeClr val="bg1"/>
-                </a:solidFill>
-              </a:rPr>
-              <a:t>asdf</a:t>
-            </a:r>
-            <a:endParaRPr lang="en-US" dirty="0">
-              <a:solidFill>
-                <a:schemeClr val="bg1"/>
-              </a:solidFill>
-            </a:endParaRPr>
+              <a:t> algorithms imitate biology in computation by using a randomly generated ‘population’ of candidate tours, which are then modified</a:t>
+            </a:r>
           </a:p>
         </p:txBody>
       </p:sp>
@@ -6567,7 +6288,7 @@
         <p:spPr>
           <a:xfrm>
             <a:off x="417443" y="1855304"/>
-            <a:ext cx="11178209" cy="4524315"/>
+            <a:ext cx="11178209" cy="2814617"/>
           </a:xfrm>
           <a:prstGeom prst="rect">
             <a:avLst/>
@@ -6580,221 +6301,87 @@
           </a:bodyPr>
           <a:lstStyle/>
           <a:p>
-            <a:r>
-              <a:rPr lang="en-US" dirty="0">
+            <a:pPr>
+              <a:lnSpc>
+                <a:spcPct val="150000"/>
+              </a:lnSpc>
+            </a:pPr>
+            <a:r>
+              <a:rPr lang="en-US" sz="2000" dirty="0">
                 <a:solidFill>
                   <a:schemeClr val="bg1"/>
                 </a:solidFill>
               </a:rPr>
-              <a:t>Four score and seven years ago,</a:t>
-            </a:r>
-          </a:p>
-          <a:p>
-            <a:r>
-              <a:rPr lang="en-US" dirty="0">
+              <a:t>While Genetic Algorithms are an easily parallelable in theory, there are many design challenges to consider:</a:t>
+            </a:r>
+          </a:p>
+          <a:p>
+            <a:pPr marL="285750" indent="-285750">
+              <a:lnSpc>
+                <a:spcPct val="150000"/>
+              </a:lnSpc>
+              <a:buFont typeface="Arial" panose="020B0604020202020204" pitchFamily="34" charset="0"/>
+              <a:buChar char="•"/>
+            </a:pPr>
+            <a:r>
+              <a:rPr lang="en-US" sz="2000" dirty="0">
                 <a:solidFill>
                   <a:schemeClr val="bg1"/>
                 </a:solidFill>
               </a:rPr>
-              <a:t>Blay </a:t>
-            </a:r>
-            <a:r>
-              <a:rPr lang="en-US" dirty="0" err="1">
+              <a:t>Where and how to represent the candidate populations in memory</a:t>
+            </a:r>
+          </a:p>
+          <a:p>
+            <a:pPr marL="285750" indent="-285750">
+              <a:lnSpc>
+                <a:spcPct val="150000"/>
+              </a:lnSpc>
+              <a:buFont typeface="Arial" panose="020B0604020202020204" pitchFamily="34" charset="0"/>
+              <a:buChar char="•"/>
+            </a:pPr>
+            <a:r>
+              <a:rPr lang="en-US" sz="2000" dirty="0">
                 <a:solidFill>
                   <a:schemeClr val="bg1"/>
                 </a:solidFill>
               </a:rPr>
-              <a:t>blahasdf</a:t>
-            </a:r>
-            <a:endParaRPr lang="en-US" dirty="0">
-              <a:solidFill>
-                <a:schemeClr val="bg1"/>
-              </a:solidFill>
-            </a:endParaRPr>
-          </a:p>
-          <a:p>
-            <a:r>
-              <a:rPr lang="en-US" dirty="0" err="1">
+              <a:t>How to communicate between blocks to allow cross mutation</a:t>
+            </a:r>
+          </a:p>
+          <a:p>
+            <a:pPr marL="285750" indent="-285750">
+              <a:lnSpc>
+                <a:spcPct val="150000"/>
+              </a:lnSpc>
+              <a:buFont typeface="Arial" panose="020B0604020202020204" pitchFamily="34" charset="0"/>
+              <a:buChar char="•"/>
+            </a:pPr>
+            <a:r>
+              <a:rPr lang="en-US" sz="2000" dirty="0">
                 <a:solidFill>
                   <a:schemeClr val="bg1"/>
                 </a:solidFill>
               </a:rPr>
-              <a:t>Asdf</a:t>
-            </a:r>
-            <a:endParaRPr lang="en-US" dirty="0">
-              <a:solidFill>
-                <a:schemeClr val="bg1"/>
-              </a:solidFill>
-            </a:endParaRPr>
-          </a:p>
-          <a:p>
-            <a:r>
-              <a:rPr lang="en-US" dirty="0" err="1">
+              <a:t>How to store the distance matrix to facilitate tour distance evaluation</a:t>
+            </a:r>
+          </a:p>
+          <a:p>
+            <a:pPr marL="285750" indent="-285750">
+              <a:lnSpc>
+                <a:spcPct val="150000"/>
+              </a:lnSpc>
+              <a:buFont typeface="Arial" panose="020B0604020202020204" pitchFamily="34" charset="0"/>
+              <a:buChar char="•"/>
+            </a:pPr>
+            <a:r>
+              <a:rPr lang="en-US" sz="2000" dirty="0">
                 <a:solidFill>
                   <a:schemeClr val="bg1"/>
                 </a:solidFill>
               </a:rPr>
-              <a:t>Asdf</a:t>
-            </a:r>
-            <a:endParaRPr lang="en-US" dirty="0">
-              <a:solidFill>
-                <a:schemeClr val="bg1"/>
-              </a:solidFill>
-            </a:endParaRPr>
-          </a:p>
-          <a:p>
-            <a:r>
-              <a:rPr lang="en-US" dirty="0">
-                <a:solidFill>
-                  <a:schemeClr val="bg1"/>
-                </a:solidFill>
-              </a:rPr>
-              <a:t>As</a:t>
-            </a:r>
-          </a:p>
-          <a:p>
-            <a:r>
-              <a:rPr lang="en-US" dirty="0" err="1">
-                <a:solidFill>
-                  <a:schemeClr val="bg1"/>
-                </a:solidFill>
-              </a:rPr>
-              <a:t>Fd</a:t>
-            </a:r>
-            <a:endParaRPr lang="en-US" dirty="0">
-              <a:solidFill>
-                <a:schemeClr val="bg1"/>
-              </a:solidFill>
-            </a:endParaRPr>
-          </a:p>
-          <a:p>
-            <a:r>
-              <a:rPr lang="en-US" dirty="0" err="1">
-                <a:solidFill>
-                  <a:schemeClr val="bg1"/>
-                </a:solidFill>
-              </a:rPr>
-              <a:t>Asdfas</a:t>
-            </a:r>
-            <a:endParaRPr lang="en-US" dirty="0">
-              <a:solidFill>
-                <a:schemeClr val="bg1"/>
-              </a:solidFill>
-            </a:endParaRPr>
-          </a:p>
-          <a:p>
-            <a:r>
-              <a:rPr lang="en-US" dirty="0" err="1">
-                <a:solidFill>
-                  <a:schemeClr val="bg1"/>
-                </a:solidFill>
-              </a:rPr>
-              <a:t>Df</a:t>
-            </a:r>
-            <a:endParaRPr lang="en-US" dirty="0">
-              <a:solidFill>
-                <a:schemeClr val="bg1"/>
-              </a:solidFill>
-            </a:endParaRPr>
-          </a:p>
-          <a:p>
-            <a:endParaRPr lang="en-US" dirty="0">
-              <a:solidFill>
-                <a:schemeClr val="bg1"/>
-              </a:solidFill>
-            </a:endParaRPr>
-          </a:p>
-          <a:p>
-            <a:r>
-              <a:rPr lang="en-US" dirty="0" err="1">
-                <a:solidFill>
-                  <a:schemeClr val="bg1"/>
-                </a:solidFill>
-              </a:rPr>
-              <a:t>Dsf</a:t>
-            </a:r>
-            <a:endParaRPr lang="en-US" dirty="0">
-              <a:solidFill>
-                <a:schemeClr val="bg1"/>
-              </a:solidFill>
-            </a:endParaRPr>
-          </a:p>
-          <a:p>
-            <a:r>
-              <a:rPr lang="en-US" dirty="0" err="1">
-                <a:solidFill>
-                  <a:schemeClr val="bg1"/>
-                </a:solidFill>
-              </a:rPr>
-              <a:t>Asd</a:t>
-            </a:r>
-            <a:endParaRPr lang="en-US" dirty="0">
-              <a:solidFill>
-                <a:schemeClr val="bg1"/>
-              </a:solidFill>
-            </a:endParaRPr>
-          </a:p>
-          <a:p>
-            <a:r>
-              <a:rPr lang="en-US" dirty="0">
-                <a:solidFill>
-                  <a:schemeClr val="bg1"/>
-                </a:solidFill>
-              </a:rPr>
-              <a:t>F</a:t>
-            </a:r>
-          </a:p>
-          <a:p>
-            <a:r>
-              <a:rPr lang="en-US" dirty="0" err="1">
-                <a:solidFill>
-                  <a:schemeClr val="bg1"/>
-                </a:solidFill>
-              </a:rPr>
-              <a:t>Asdf</a:t>
-            </a:r>
-            <a:endParaRPr lang="en-US" dirty="0">
-              <a:solidFill>
-                <a:schemeClr val="bg1"/>
-              </a:solidFill>
-            </a:endParaRPr>
-          </a:p>
-          <a:p>
-            <a:r>
-              <a:rPr lang="en-US" dirty="0" err="1">
-                <a:solidFill>
-                  <a:schemeClr val="bg1"/>
-                </a:solidFill>
-              </a:rPr>
-              <a:t>Asdf</a:t>
-            </a:r>
-            <a:endParaRPr lang="en-US" dirty="0">
-              <a:solidFill>
-                <a:schemeClr val="bg1"/>
-              </a:solidFill>
-            </a:endParaRPr>
-          </a:p>
-          <a:p>
-            <a:endParaRPr lang="en-US" dirty="0">
-              <a:solidFill>
-                <a:schemeClr val="bg1"/>
-              </a:solidFill>
-            </a:endParaRPr>
-          </a:p>
-          <a:p>
-            <a:r>
-              <a:rPr lang="en-US" dirty="0" err="1">
-                <a:solidFill>
-                  <a:schemeClr val="bg1"/>
-                </a:solidFill>
-              </a:rPr>
-              <a:t>asdf</a:t>
-            </a:r>
-            <a:endParaRPr lang="en-US" dirty="0">
-              <a:solidFill>
-                <a:schemeClr val="bg1"/>
-              </a:solidFill>
-            </a:endParaRPr>
+              <a:t>Tuning the GA numbers to</a:t>
+            </a:r>
           </a:p>
         </p:txBody>
       </p:sp>
@@ -6887,7 +6474,7 @@
         <p:spPr>
           <a:xfrm>
             <a:off x="417443" y="1855304"/>
-            <a:ext cx="11178209" cy="4524315"/>
+            <a:ext cx="11178209" cy="3046988"/>
           </a:xfrm>
           <a:prstGeom prst="rect">
             <a:avLst/>
@@ -6901,220 +6488,47 @@
           <a:lstStyle/>
           <a:p>
             <a:r>
-              <a:rPr lang="en-US" dirty="0">
+              <a:rPr lang="en-US" sz="2400" dirty="0">
                 <a:solidFill>
                   <a:schemeClr val="bg1"/>
                 </a:solidFill>
               </a:rPr>
-              <a:t>Four score and seven years ago,</a:t>
-            </a:r>
-          </a:p>
-          <a:p>
-            <a:r>
-              <a:rPr lang="en-US" dirty="0">
+              <a:t>The most basic approach involves writing a very greedy algorithm which simply chooses the closest neighbor from the current node and creates a tour in this fashion iteratively</a:t>
+            </a:r>
+          </a:p>
+          <a:p>
+            <a:endParaRPr lang="en-US" sz="2400" dirty="0">
+              <a:solidFill>
+                <a:schemeClr val="bg1"/>
+              </a:solidFill>
+            </a:endParaRPr>
+          </a:p>
+          <a:p>
+            <a:r>
+              <a:rPr lang="en-US" sz="2400" dirty="0">
                 <a:solidFill>
                   <a:schemeClr val="bg1"/>
                 </a:solidFill>
               </a:rPr>
-              <a:t>Blay </a:t>
-            </a:r>
-            <a:r>
-              <a:rPr lang="en-US" dirty="0" err="1">
+              <a:t>This tour is of course not very good, but it does generate a useful heuristic to feed an elite population member to the Genetic algorithm portion.</a:t>
+            </a:r>
+          </a:p>
+          <a:p>
+            <a:endParaRPr lang="en-US" sz="2400" dirty="0">
+              <a:solidFill>
+                <a:schemeClr val="bg1"/>
+              </a:solidFill>
+            </a:endParaRPr>
+          </a:p>
+          <a:p>
+            <a:r>
+              <a:rPr lang="en-US" sz="2400" dirty="0">
                 <a:solidFill>
                   <a:schemeClr val="bg1"/>
                 </a:solidFill>
               </a:rPr>
-              <a:t>blahasdf</a:t>
-            </a:r>
-            <a:endParaRPr lang="en-US" dirty="0">
-              <a:solidFill>
-                <a:schemeClr val="bg1"/>
-              </a:solidFill>
-            </a:endParaRPr>
-          </a:p>
-          <a:p>
-            <a:r>
-              <a:rPr lang="en-US" dirty="0" err="1">
-                <a:solidFill>
-                  <a:schemeClr val="bg1"/>
-                </a:solidFill>
-              </a:rPr>
-              <a:t>Asdf</a:t>
-            </a:r>
-            <a:endParaRPr lang="en-US" dirty="0">
-              <a:solidFill>
-                <a:schemeClr val="bg1"/>
-              </a:solidFill>
-            </a:endParaRPr>
-          </a:p>
-          <a:p>
-            <a:r>
-              <a:rPr lang="en-US" dirty="0" err="1">
-                <a:solidFill>
-                  <a:schemeClr val="bg1"/>
-                </a:solidFill>
-              </a:rPr>
-              <a:t>Asdf</a:t>
-            </a:r>
-            <a:endParaRPr lang="en-US" dirty="0">
-              <a:solidFill>
-                <a:schemeClr val="bg1"/>
-              </a:solidFill>
-            </a:endParaRPr>
-          </a:p>
-          <a:p>
-            <a:r>
-              <a:rPr lang="en-US" dirty="0">
-                <a:solidFill>
-                  <a:schemeClr val="bg1"/>
-                </a:solidFill>
-              </a:rPr>
-              <a:t>As</a:t>
-            </a:r>
-          </a:p>
-          <a:p>
-            <a:r>
-              <a:rPr lang="en-US" dirty="0" err="1">
-                <a:solidFill>
-                  <a:schemeClr val="bg1"/>
-                </a:solidFill>
-              </a:rPr>
-              <a:t>Fd</a:t>
-            </a:r>
-            <a:endParaRPr lang="en-US" dirty="0">
-              <a:solidFill>
-                <a:schemeClr val="bg1"/>
-              </a:solidFill>
-            </a:endParaRPr>
-          </a:p>
-          <a:p>
-            <a:r>
-              <a:rPr lang="en-US" dirty="0" err="1">
-                <a:solidFill>
-                  <a:schemeClr val="bg1"/>
-                </a:solidFill>
-              </a:rPr>
-              <a:t>Asdfas</a:t>
-            </a:r>
-            <a:endParaRPr lang="en-US" dirty="0">
-              <a:solidFill>
-                <a:schemeClr val="bg1"/>
-              </a:solidFill>
-            </a:endParaRPr>
-          </a:p>
-          <a:p>
-            <a:r>
-              <a:rPr lang="en-US" dirty="0" err="1">
-                <a:solidFill>
-                  <a:schemeClr val="bg1"/>
-                </a:solidFill>
-              </a:rPr>
-              <a:t>Df</a:t>
-            </a:r>
-            <a:endParaRPr lang="en-US" dirty="0">
-              <a:solidFill>
-                <a:schemeClr val="bg1"/>
-              </a:solidFill>
-            </a:endParaRPr>
-          </a:p>
-          <a:p>
-            <a:endParaRPr lang="en-US" dirty="0">
-              <a:solidFill>
-                <a:schemeClr val="bg1"/>
-              </a:solidFill>
-            </a:endParaRPr>
-          </a:p>
-          <a:p>
-            <a:r>
-              <a:rPr lang="en-US" dirty="0" err="1">
-                <a:solidFill>
-                  <a:schemeClr val="bg1"/>
-                </a:solidFill>
-              </a:rPr>
-              <a:t>Dsf</a:t>
-            </a:r>
-            <a:endParaRPr lang="en-US" dirty="0">
-              <a:solidFill>
-                <a:schemeClr val="bg1"/>
-              </a:solidFill>
-            </a:endParaRPr>
-          </a:p>
-          <a:p>
-            <a:r>
-              <a:rPr lang="en-US" dirty="0" err="1">
-                <a:solidFill>
-                  <a:schemeClr val="bg1"/>
-                </a:solidFill>
-              </a:rPr>
-              <a:t>Asd</a:t>
-            </a:r>
-            <a:endParaRPr lang="en-US" dirty="0">
-              <a:solidFill>
-                <a:schemeClr val="bg1"/>
-              </a:solidFill>
-            </a:endParaRPr>
-          </a:p>
-          <a:p>
-            <a:r>
-              <a:rPr lang="en-US" dirty="0">
-                <a:solidFill>
-                  <a:schemeClr val="bg1"/>
-                </a:solidFill>
-              </a:rPr>
-              <a:t>F</a:t>
-            </a:r>
-          </a:p>
-          <a:p>
-            <a:r>
-              <a:rPr lang="en-US" dirty="0" err="1">
-                <a:solidFill>
-                  <a:schemeClr val="bg1"/>
-                </a:solidFill>
-              </a:rPr>
-              <a:t>Asdf</a:t>
-            </a:r>
-            <a:endParaRPr lang="en-US" dirty="0">
-              <a:solidFill>
-                <a:schemeClr val="bg1"/>
-              </a:solidFill>
-            </a:endParaRPr>
-          </a:p>
-          <a:p>
-            <a:r>
-              <a:rPr lang="en-US" dirty="0" err="1">
-                <a:solidFill>
-                  <a:schemeClr val="bg1"/>
-                </a:solidFill>
-              </a:rPr>
-              <a:t>Asdf</a:t>
-            </a:r>
-            <a:endParaRPr lang="en-US" dirty="0">
-              <a:solidFill>
-                <a:schemeClr val="bg1"/>
-              </a:solidFill>
-            </a:endParaRPr>
-          </a:p>
-          <a:p>
-            <a:endParaRPr lang="en-US" dirty="0">
-              <a:solidFill>
-                <a:schemeClr val="bg1"/>
-              </a:solidFill>
-            </a:endParaRPr>
-          </a:p>
-          <a:p>
-            <a:r>
-              <a:rPr lang="en-US" dirty="0" err="1">
-                <a:solidFill>
-                  <a:schemeClr val="bg1"/>
-                </a:solidFill>
-              </a:rPr>
-              <a:t>asdf</a:t>
-            </a:r>
-            <a:endParaRPr lang="en-US" dirty="0">
-              <a:solidFill>
-                <a:schemeClr val="bg1"/>
-              </a:solidFill>
-            </a:endParaRPr>
+              <a:t>This tour was evaluated using the GPU kernel, and tuned and optimize, since the fitness evaluation function will be called very often.</a:t>
+            </a:r>
           </a:p>
         </p:txBody>
       </p:sp>
@@ -7207,7 +6621,7 @@
         <p:spPr>
           <a:xfrm>
             <a:off x="417443" y="1855304"/>
-            <a:ext cx="11178209" cy="4524315"/>
+            <a:ext cx="11178209" cy="646331"/>
           </a:xfrm>
           <a:prstGeom prst="rect">
             <a:avLst/>
@@ -7226,215 +6640,8 @@
                   <a:schemeClr val="bg1"/>
                 </a:solidFill>
               </a:rPr>
-              <a:t>Four score and seven years ago,</a:t>
-            </a:r>
-          </a:p>
-          <a:p>
-            <a:r>
-              <a:rPr lang="en-US" dirty="0">
-                <a:solidFill>
-                  <a:schemeClr val="bg1"/>
-                </a:solidFill>
-              </a:rPr>
-              <a:t>Blay </a:t>
-            </a:r>
-            <a:r>
-              <a:rPr lang="en-US" dirty="0" err="1">
-                <a:solidFill>
-                  <a:schemeClr val="bg1"/>
-                </a:solidFill>
-              </a:rPr>
-              <a:t>blahasdf</a:t>
-            </a:r>
-            <a:endParaRPr lang="en-US" dirty="0">
-              <a:solidFill>
-                <a:schemeClr val="bg1"/>
-              </a:solidFill>
-            </a:endParaRPr>
-          </a:p>
-          <a:p>
-            <a:r>
-              <a:rPr lang="en-US" dirty="0" err="1">
-                <a:solidFill>
-                  <a:schemeClr val="bg1"/>
-                </a:solidFill>
-              </a:rPr>
-              <a:t>Asdf</a:t>
-            </a:r>
-            <a:endParaRPr lang="en-US" dirty="0">
-              <a:solidFill>
-                <a:schemeClr val="bg1"/>
-              </a:solidFill>
-            </a:endParaRPr>
-          </a:p>
-          <a:p>
-            <a:r>
-              <a:rPr lang="en-US" dirty="0" err="1">
-                <a:solidFill>
-                  <a:schemeClr val="bg1"/>
-                </a:solidFill>
-              </a:rPr>
-              <a:t>Asdf</a:t>
-            </a:r>
-            <a:endParaRPr lang="en-US" dirty="0">
-              <a:solidFill>
-                <a:schemeClr val="bg1"/>
-              </a:solidFill>
-            </a:endParaRPr>
-          </a:p>
-          <a:p>
-            <a:r>
-              <a:rPr lang="en-US" dirty="0">
-                <a:solidFill>
-                  <a:schemeClr val="bg1"/>
-                </a:solidFill>
-              </a:rPr>
-              <a:t>As</a:t>
-            </a:r>
-          </a:p>
-          <a:p>
-            <a:r>
-              <a:rPr lang="en-US" dirty="0" err="1">
-                <a:solidFill>
-                  <a:schemeClr val="bg1"/>
-                </a:solidFill>
-              </a:rPr>
-              <a:t>Fd</a:t>
-            </a:r>
-            <a:endParaRPr lang="en-US" dirty="0">
-              <a:solidFill>
-                <a:schemeClr val="bg1"/>
-              </a:solidFill>
-            </a:endParaRPr>
-          </a:p>
-          <a:p>
-            <a:r>
-              <a:rPr lang="en-US" dirty="0" err="1">
-                <a:solidFill>
-                  <a:schemeClr val="bg1"/>
-                </a:solidFill>
-              </a:rPr>
-              <a:t>Asdfas</a:t>
-            </a:r>
-            <a:endParaRPr lang="en-US" dirty="0">
-              <a:solidFill>
-                <a:schemeClr val="bg1"/>
-              </a:solidFill>
-            </a:endParaRPr>
-          </a:p>
-          <a:p>
-            <a:r>
-              <a:rPr lang="en-US" dirty="0" err="1">
-                <a:solidFill>
-                  <a:schemeClr val="bg1"/>
-                </a:solidFill>
-              </a:rPr>
-              <a:t>Df</a:t>
-            </a:r>
-            <a:endParaRPr lang="en-US" dirty="0">
-              <a:solidFill>
-                <a:schemeClr val="bg1"/>
-              </a:solidFill>
-            </a:endParaRPr>
-          </a:p>
-          <a:p>
-            <a:endParaRPr lang="en-US" dirty="0">
-              <a:solidFill>
-                <a:schemeClr val="bg1"/>
-              </a:solidFill>
-            </a:endParaRPr>
-          </a:p>
-          <a:p>
-            <a:r>
-              <a:rPr lang="en-US" dirty="0" err="1">
-                <a:solidFill>
-                  <a:schemeClr val="bg1"/>
-                </a:solidFill>
-              </a:rPr>
-              <a:t>Dsf</a:t>
-            </a:r>
-            <a:endParaRPr lang="en-US" dirty="0">
-              <a:solidFill>
-                <a:schemeClr val="bg1"/>
-              </a:solidFill>
-            </a:endParaRPr>
-          </a:p>
-          <a:p>
-            <a:r>
-              <a:rPr lang="en-US" dirty="0" err="1">
-                <a:solidFill>
-                  <a:schemeClr val="bg1"/>
-                </a:solidFill>
-              </a:rPr>
-              <a:t>Asd</a:t>
-            </a:r>
-            <a:endParaRPr lang="en-US" dirty="0">
-              <a:solidFill>
-                <a:schemeClr val="bg1"/>
-              </a:solidFill>
-            </a:endParaRPr>
-          </a:p>
-          <a:p>
-            <a:r>
-              <a:rPr lang="en-US" dirty="0">
-                <a:solidFill>
-                  <a:schemeClr val="bg1"/>
-                </a:solidFill>
-              </a:rPr>
-              <a:t>F</a:t>
-            </a:r>
-          </a:p>
-          <a:p>
-            <a:r>
-              <a:rPr lang="en-US" dirty="0" err="1">
-                <a:solidFill>
-                  <a:schemeClr val="bg1"/>
-                </a:solidFill>
-              </a:rPr>
-              <a:t>Asdf</a:t>
-            </a:r>
-            <a:endParaRPr lang="en-US" dirty="0">
-              <a:solidFill>
-                <a:schemeClr val="bg1"/>
-              </a:solidFill>
-            </a:endParaRPr>
-          </a:p>
-          <a:p>
-            <a:r>
-              <a:rPr lang="en-US" dirty="0" err="1">
-                <a:solidFill>
-                  <a:schemeClr val="bg1"/>
-                </a:solidFill>
-              </a:rPr>
-              <a:t>Asdf</a:t>
-            </a:r>
-            <a:endParaRPr lang="en-US" dirty="0">
-              <a:solidFill>
-                <a:schemeClr val="bg1"/>
-              </a:solidFill>
-            </a:endParaRPr>
-          </a:p>
-          <a:p>
-            <a:endParaRPr lang="en-US" dirty="0">
-              <a:solidFill>
-                <a:schemeClr val="bg1"/>
-              </a:solidFill>
-            </a:endParaRPr>
-          </a:p>
-          <a:p>
-            <a:r>
-              <a:rPr lang="en-US" dirty="0" err="1">
-                <a:solidFill>
-                  <a:schemeClr val="bg1"/>
-                </a:solidFill>
-              </a:rPr>
-              <a:t>asdf</a:t>
-            </a:r>
-            <a:endParaRPr lang="en-US" dirty="0">
-              <a:solidFill>
-                <a:schemeClr val="bg1"/>
-              </a:solidFill>
-            </a:endParaRPr>
+              <a:t>After implementing fitness evaluation the next step is to get the most simple form of Genetic Algorithms running in a parallel fashion, giving a basis for further optimization.</a:t>
+            </a:r>
           </a:p>
         </p:txBody>
       </p:sp>
@@ -7527,7 +6734,7 @@
         <p:spPr>
           <a:xfrm>
             <a:off x="417443" y="1855304"/>
-            <a:ext cx="11178209" cy="1477328"/>
+            <a:ext cx="11178209" cy="3139321"/>
           </a:xfrm>
           <a:prstGeom prst="rect">
             <a:avLst/>
@@ -7539,6 +6746,39 @@
             <a:spAutoFit/>
           </a:bodyPr>
           <a:lstStyle/>
+          <a:p>
+            <a:r>
+              <a:rPr lang="en-US" dirty="0">
+                <a:solidFill>
+                  <a:schemeClr val="bg1"/>
+                </a:solidFill>
+              </a:rPr>
+              <a:t>Memory coalescing was optimized by reorganizing tour data so that neighboring CUDA threads access neighboring memory addresses at the same tour step. Instead of storing each tour contiguously and causing </a:t>
+            </a:r>
+            <a:r>
+              <a:rPr lang="en-US" dirty="0" err="1">
+                <a:solidFill>
+                  <a:schemeClr val="bg1"/>
+                </a:solidFill>
+              </a:rPr>
+              <a:t>strided</a:t>
+            </a:r>
+            <a:r>
+              <a:rPr lang="en-US" dirty="0">
+                <a:solidFill>
+                  <a:schemeClr val="bg1"/>
+                </a:solidFill>
+              </a:rPr>
+              <a:t> reads across a warp, the population can be transposed so city positions are grouped together across tours. This allows a warp to fetch consecutive city indices in fewer memory transactions, reducing global memory bandwidth waste and improving fitness-evaluation throughput.</a:t>
+            </a:r>
+          </a:p>
+          <a:p>
+            <a:endParaRPr lang="en-US" dirty="0">
+              <a:solidFill>
+                <a:schemeClr val="bg1"/>
+              </a:solidFill>
+            </a:endParaRPr>
+          </a:p>
           <a:p>
             <a:r>
               <a:rPr lang="en-US" dirty="0">
@@ -7669,7 +6909,7 @@
         <p:spPr>
           <a:xfrm>
             <a:off x="417443" y="1855304"/>
-            <a:ext cx="11178209" cy="1477328"/>
+            <a:ext cx="11178209" cy="3139321"/>
           </a:xfrm>
           <a:prstGeom prst="rect">
             <a:avLst/>
@@ -7681,6 +6921,23 @@
             <a:spAutoFit/>
           </a:bodyPr>
           <a:lstStyle/>
+          <a:p>
+            <a:r>
+              <a:rPr lang="en-US" dirty="0">
+                <a:solidFill>
+                  <a:schemeClr val="bg1"/>
+                </a:solidFill>
+              </a:rPr>
+              <a:t>2-opt can be used as a local improvement step to refine tours produced by the genetic algorithm. After crossover and mutation create a candidate route, 2-opt checks whether reversing a segment of the tour would remove crossing edges and shorten the total distance. This helps the GA converge faster by improving solution quality within each generation, though it must be applied selectively in CUDA because exhaustive 2-opt searches can add significant computation and memory-access overhead.</a:t>
+            </a:r>
+          </a:p>
+          <a:p>
+            <a:endParaRPr lang="en-US" dirty="0">
+              <a:solidFill>
+                <a:schemeClr val="bg1"/>
+              </a:solidFill>
+            </a:endParaRPr>
+          </a:p>
           <a:p>
             <a:r>
               <a:rPr lang="en-US" dirty="0">

</xml_diff>